<commit_message>
Rebuild Week 1 lecture outputs (L1.1, L1.2)
L1.2 now covers Theory of Design / Philosophy of Design; its research
questions diagram is pre-rendered to PNG so it displays correctly in
HTML, PDF, and PPTX. L1.1 HTML rebuilt to match current source.

Co-Authored-By: Claude Sonnet 5 <noreply@anthropic.com>
</commit_message>
<xml_diff>
--- a/html/COMP-_L1.1_Introduction.pptx
+++ b/html/COMP-_L1.1_Introduction.pptx
@@ -1426,7 +1426,7 @@
                 <a:latin typeface="LucidaGrande"/>
                 <a:ea typeface="LucidaGrande"/>
               </a:rPr>
-              <a:t>Version: GITREVISION | © 21.09.2026 University of Southampton</a:t>
+              <a:t>Version: GITREVISION | © 22.09.2026 University of Southampton</a:t>
             </a:r>
             <a:endParaRPr b="0" lang="en-US" sz="800" strike="noStrike" u="none">
               <a:solidFill>
@@ -3114,7 +3114,7 @@
                 <a:latin typeface="LucidaGrande"/>
                 <a:ea typeface="LucidaGrande"/>
               </a:rPr>
-              <a:t>Version: GITREVISION | © 21.09.2026 University of Southampton</a:t>
+              <a:t>Version: GITREVISION | © 22.09.2026 University of Southampton</a:t>
             </a:r>
             <a:endParaRPr b="0" lang="en-US" sz="800" strike="noStrike" u="none">
               <a:solidFill>
@@ -5421,7 +5421,7 @@
                 <a:latin typeface="LucidaGrande"/>
                 <a:ea typeface="LucidaGrande"/>
               </a:rPr>
-              <a:t>Version: GITREVISION | © 21.09.2026 University of Southampton</a:t>
+              <a:t>Version: GITREVISION | © 22.09.2026 University of Southampton</a:t>
             </a:r>
             <a:endParaRPr b="0" lang="en-US" sz="800" strike="noStrike" u="none">
               <a:solidFill>
@@ -6980,7 +6980,7 @@
                 <a:latin typeface="LucidaGrande"/>
                 <a:ea typeface="LucidaGrande"/>
               </a:rPr>
-              <a:t>Version: GITREVISION | © 21.09.2026 University of Southampton</a:t>
+              <a:t>Version: GITREVISION | © 22.09.2026 University of Southampton</a:t>
             </a:r>
             <a:endParaRPr b="0" lang="en-US" sz="800" strike="noStrike" u="none">
               <a:solidFill>
@@ -8664,7 +8664,7 @@
                 <a:latin typeface="LucidaGrande"/>
                 <a:ea typeface="LucidaGrande"/>
               </a:rPr>
-              <a:t>Version: GITREVISION | © 21.09.2026 University of Southampton</a:t>
+              <a:t>Version: GITREVISION | © 22.09.2026 University of Southampton</a:t>
             </a:r>
             <a:endParaRPr b="0" lang="en-US" sz="800" strike="noStrike" u="none">
               <a:solidFill>
@@ -9584,7 +9584,7 @@
                 <a:latin typeface="LucidaGrande"/>
                 <a:ea typeface="LucidaGrande"/>
               </a:rPr>
-              <a:t>Version: GITREVISION | © 21.09.2026 University of Southampton</a:t>
+              <a:t>Version: GITREVISION | © 22.09.2026 University of Southampton</a:t>
             </a:r>
             <a:endParaRPr b="0" lang="en-US" sz="800" strike="noStrike" u="none">
               <a:solidFill>
@@ -10306,7 +10306,7 @@
                 <a:latin typeface="LucidaGrande"/>
                 <a:ea typeface="LucidaGrande"/>
               </a:rPr>
-              <a:t>Version: GITREVISION | © 21.09.2026 University of Southampton</a:t>
+              <a:t>Version: GITREVISION | © 22.09.2026 University of Southampton</a:t>
             </a:r>
             <a:endParaRPr b="0" lang="en-US" sz="800" strike="noStrike" u="none">
               <a:solidFill>
@@ -16486,7 +16486,7 @@
                 <a:latin typeface="LucidaGrande"/>
                 <a:ea typeface="LucidaGrande"/>
               </a:rPr>
-              <a:t>Version: GITREVISION | © 21.09.2026 University of Southampton</a:t>
+              <a:t>Version: GITREVISION | © 22.09.2026 University of Southampton</a:t>
             </a:r>
             <a:endParaRPr b="0" lang="en-US" sz="800" strike="noStrike" u="none">
               <a:solidFill>
@@ -17918,7 +17918,7 @@
                 <a:latin typeface="LucidaGrande"/>
                 <a:ea typeface="LucidaGrande"/>
               </a:rPr>
-              <a:t>Version: GITREVISION | © 21.09.2026 University of Southampton</a:t>
+              <a:t>Version: GITREVISION | © 22.09.2026 University of Southampton</a:t>
             </a:r>
             <a:endParaRPr b="0" lang="en-US" sz="800" strike="noStrike" u="none">
               <a:solidFill>
@@ -19700,7 +19700,7 @@
                 <a:latin typeface="LucidaGrande"/>
                 <a:ea typeface="LucidaGrande"/>
               </a:rPr>
-              <a:t>Version: GITREVISION | © 21.09.2026 University of Southampton</a:t>
+              <a:t>Version: GITREVISION | © 22.09.2026 University of Southampton</a:t>
             </a:r>
             <a:endParaRPr b="0" lang="en-US" sz="800" strike="noStrike" u="none">
               <a:solidFill>
@@ -20663,7 +20663,7 @@
                 <a:latin typeface="LucidaGrande"/>
                 <a:ea typeface="LucidaGrande"/>
               </a:rPr>
-              <a:t>Version: GITREVISION | © 21.09.2026 University of Southampton</a:t>
+              <a:t>Version: GITREVISION | © 22.09.2026 University of Southampton</a:t>
             </a:r>
             <a:endParaRPr b="0" lang="en-US" sz="800" strike="noStrike" u="none">
               <a:solidFill>
@@ -23702,7 +23702,7 @@
                 <a:latin typeface="LucidaGrande"/>
                 <a:ea typeface="LucidaGrande"/>
               </a:rPr>
-              <a:t>Version: GITREVISION | © 21.09.2026 University of Southampton</a:t>
+              <a:t>Version: GITREVISION | © 22.09.2026 University of Southampton</a:t>
             </a:r>
             <a:endParaRPr b="0" lang="en-US" sz="800" strike="noStrike" u="none">
               <a:solidFill>

</xml_diff>